<commit_message>
feat: home redesign, emoji-free icons, smoother animations, quiz review + LaTeX fixes
</commit_message>
<xml_diff>
--- a/Ooka_ePoster.pptx
+++ b/Ooka_ePoster.pptx
@@ -4716,12 +4716,15 @@
           <a:lstStyle/>
           <a:p>
             <a:pPr algn="l">
+              <a:spcBef>
+                <a:spcPts val="0"/>
+              </a:spcBef>
               <a:spcAft>
                 <a:spcPts val="500"/>
               </a:spcAft>
             </a:pPr>
             <a:r>
-              <a:rPr sz="4200" b="1">
+              <a:rPr sz="4000" b="1">
                 <a:solidFill>
                   <a:srgbClr val="B23E65"/>
                 </a:solidFill>
@@ -4737,13 +4740,40 @@
               </a:spcAft>
             </a:pPr>
             <a:r>
-              <a:rPr sz="2700" b="0">
-                <a:solidFill>
-                  <a:srgbClr val="22303C"/>
-                </a:solidFill>
-                <a:latin typeface="Century Gothic"/>
-              </a:rPr>
-              <a:t>•  Curious Lab is a Singapore EdTech company that builds digital tools to help students study more effectively.</a:t>
+              <a:rPr sz="2500" b="0">
+                <a:solidFill>
+                  <a:srgbClr val="22303C"/>
+                </a:solidFill>
+                <a:latin typeface="Century Gothic"/>
+              </a:rPr>
+              <a:t>•  </a:t>
+            </a:r>
+            <a:r>
+              <a:rPr sz="2500" b="0">
+                <a:solidFill>
+                  <a:srgbClr val="22303C"/>
+                </a:solidFill>
+                <a:latin typeface="Century Gothic"/>
+              </a:rPr>
+              <a:t>Curious Lab is a Singapore </a:t>
+            </a:r>
+            <a:r>
+              <a:rPr sz="2500" b="1">
+                <a:solidFill>
+                  <a:srgbClr val="22303C"/>
+                </a:solidFill>
+                <a:latin typeface="Century Gothic"/>
+              </a:rPr>
+              <a:t>educational-technology company</a:t>
+            </a:r>
+            <a:r>
+              <a:rPr sz="2500" b="0">
+                <a:solidFill>
+                  <a:srgbClr val="22303C"/>
+                </a:solidFill>
+                <a:latin typeface="Century Gothic"/>
+              </a:rPr>
+              <a:t> that builds digital products to help students learn.</a:t>
             </a:r>
           </a:p>
           <a:p>
@@ -4753,26 +4783,53 @@
               </a:spcAft>
             </a:pPr>
             <a:r>
-              <a:rPr sz="2700" b="0">
-                <a:solidFill>
-                  <a:srgbClr val="22303C"/>
-                </a:solidFill>
-                <a:latin typeface="Century Gothic"/>
-              </a:rPr>
-              <a:t>•  It turns real exam material into engaging, self-directed practice for O-Level and PSLE students.</a:t>
+              <a:rPr sz="2500" b="0">
+                <a:solidFill>
+                  <a:srgbClr val="22303C"/>
+                </a:solidFill>
+                <a:latin typeface="Century Gothic"/>
+              </a:rPr>
+              <a:t>•  </a:t>
+            </a:r>
+            <a:r>
+              <a:rPr sz="2500" b="0">
+                <a:solidFill>
+                  <a:srgbClr val="22303C"/>
+                </a:solidFill>
+                <a:latin typeface="Century Gothic"/>
+              </a:rPr>
+              <a:t>Works with </a:t>
+            </a:r>
+            <a:r>
+              <a:rPr sz="2500" b="1">
+                <a:solidFill>
+                  <a:srgbClr val="22303C"/>
+                </a:solidFill>
+                <a:latin typeface="Century Gothic"/>
+              </a:rPr>
+              <a:t>primary and secondary school students</a:t>
+            </a:r>
+            <a:r>
+              <a:rPr sz="2500" b="0">
+                <a:solidFill>
+                  <a:srgbClr val="22303C"/>
+                </a:solidFill>
+                <a:latin typeface="Century Gothic"/>
+              </a:rPr>
+              <a:t>, making studying more effective and consistent.</a:t>
             </a:r>
           </a:p>
           <a:p>
             <a:pPr algn="l">
               <a:spcBef>
-                <a:spcPts val="1600"/>
+                <a:spcPts val="1400"/>
               </a:spcBef>
               <a:spcAft>
                 <a:spcPts val="500"/>
               </a:spcAft>
             </a:pPr>
             <a:r>
-              <a:rPr sz="4200" b="1">
+              <a:rPr sz="4000" b="1">
                 <a:solidFill>
                   <a:srgbClr val="B23E65"/>
                 </a:solidFill>
@@ -4788,13 +4845,31 @@
               </a:spcAft>
             </a:pPr>
             <a:r>
-              <a:rPr sz="2700" b="0">
-                <a:solidFill>
-                  <a:srgbClr val="22303C"/>
-                </a:solidFill>
-                <a:latin typeface="Century Gothic"/>
-              </a:rPr>
-              <a:t>•  Full-stack developer for Ooka, the company's gamified study app.</a:t>
+              <a:rPr sz="2500" b="0">
+                <a:solidFill>
+                  <a:srgbClr val="22303C"/>
+                </a:solidFill>
+                <a:latin typeface="Century Gothic"/>
+              </a:rPr>
+              <a:t>•  </a:t>
+            </a:r>
+            <a:r>
+              <a:rPr sz="2500" b="1">
+                <a:solidFill>
+                  <a:srgbClr val="22303C"/>
+                </a:solidFill>
+                <a:latin typeface="Century Gothic"/>
+              </a:rPr>
+              <a:t>Sole full-stack developer</a:t>
+            </a:r>
+            <a:r>
+              <a:rPr sz="2500" b="0">
+                <a:solidFill>
+                  <a:srgbClr val="22303C"/>
+                </a:solidFill>
+                <a:latin typeface="Century Gothic"/>
+              </a:rPr>
+              <a:t>: designed, built and ran the whole system.</a:t>
             </a:r>
           </a:p>
           <a:p>
@@ -4804,13 +4879,40 @@
               </a:spcAft>
             </a:pPr>
             <a:r>
-              <a:rPr sz="2700" b="0">
-                <a:solidFill>
-                  <a:srgbClr val="22303C"/>
-                </a:solidFill>
-                <a:latin typeface="Century Gothic"/>
-              </a:rPr>
-              <a:t>•  Built an automated pipeline that extracts questions, answers and diagrams from exam papers.</a:t>
+              <a:rPr sz="2500" b="0">
+                <a:solidFill>
+                  <a:srgbClr val="22303C"/>
+                </a:solidFill>
+                <a:latin typeface="Century Gothic"/>
+              </a:rPr>
+              <a:t>•  </a:t>
+            </a:r>
+            <a:r>
+              <a:rPr sz="2500" b="0">
+                <a:solidFill>
+                  <a:srgbClr val="22303C"/>
+                </a:solidFill>
+                <a:latin typeface="Century Gothic"/>
+              </a:rPr>
+              <a:t>Built an </a:t>
+            </a:r>
+            <a:r>
+              <a:rPr sz="2500" b="1">
+                <a:solidFill>
+                  <a:srgbClr val="22303C"/>
+                </a:solidFill>
+                <a:latin typeface="Century Gothic"/>
+              </a:rPr>
+              <a:t>OCR + LLM pipeline</a:t>
+            </a:r>
+            <a:r>
+              <a:rPr sz="2500" b="0">
+                <a:solidFill>
+                  <a:srgbClr val="22303C"/>
+                </a:solidFill>
+                <a:latin typeface="Century Gothic"/>
+              </a:rPr>
+              <a:t> that extracts questions, answers and diagrams from exam papers.</a:t>
             </a:r>
           </a:p>
           <a:p>
@@ -4820,13 +4922,58 @@
               </a:spcAft>
             </a:pPr>
             <a:r>
-              <a:rPr sz="2700" b="0">
-                <a:solidFill>
-                  <a:srgbClr val="22303C"/>
-                </a:solidFill>
-                <a:latin typeface="Century Gothic"/>
-              </a:rPr>
-              <a:t>•  Developed the app front end (React) and back end (FastAPI + MySQL).</a:t>
+              <a:rPr sz="2500" b="0">
+                <a:solidFill>
+                  <a:srgbClr val="22303C"/>
+                </a:solidFill>
+                <a:latin typeface="Century Gothic"/>
+              </a:rPr>
+              <a:t>•  </a:t>
+            </a:r>
+            <a:r>
+              <a:rPr sz="2500" b="0">
+                <a:solidFill>
+                  <a:srgbClr val="22303C"/>
+                </a:solidFill>
+                <a:latin typeface="Century Gothic"/>
+              </a:rPr>
+              <a:t>Developed the </a:t>
+            </a:r>
+            <a:r>
+              <a:rPr sz="2500" b="1">
+                <a:solidFill>
+                  <a:srgbClr val="22303C"/>
+                </a:solidFill>
+                <a:latin typeface="Century Gothic"/>
+              </a:rPr>
+              <a:t>React front end</a:t>
+            </a:r>
+            <a:r>
+              <a:rPr sz="2500" b="0">
+                <a:solidFill>
+                  <a:srgbClr val="22303C"/>
+                </a:solidFill>
+                <a:latin typeface="Century Gothic"/>
+              </a:rPr>
+              <a:t> and </a:t>
+            </a:r>
+            <a:r>
+              <a:rPr sz="2500" b="1">
+                <a:solidFill>
+                  <a:srgbClr val="22303C"/>
+                </a:solidFill>
+                <a:latin typeface="Century Gothic"/>
+              </a:rPr>
+              <a:t>FastAPI + MySQL back end</a:t>
+            </a:r>
+            <a:r>
+              <a:rPr sz="2500" b="0">
+                <a:solidFill>
+                  <a:srgbClr val="22303C"/>
+                </a:solidFill>
+                <a:latin typeface="Century Gothic"/>
+              </a:rPr>
+              <a:t>: quizzes, streaks, XP, leaderboard, avatar shop, teacher dashboard.</a:t>
             </a:r>
           </a:p>
           <a:p>
@@ -4836,32 +4983,84 @@
               </a:spcAft>
             </a:pPr>
             <a:r>
-              <a:rPr sz="2700" b="0">
-                <a:solidFill>
-                  <a:srgbClr val="22303C"/>
-                </a:solidFill>
-                <a:latin typeface="Century Gothic"/>
-              </a:rPr>
-              <a:t>•  Deployed and maintained the app on the cloud.</a:t>
+              <a:rPr sz="2500" b="0">
+                <a:solidFill>
+                  <a:srgbClr val="22303C"/>
+                </a:solidFill>
+                <a:latin typeface="Century Gothic"/>
+              </a:rPr>
+              <a:t>•  </a:t>
+            </a:r>
+            <a:r>
+              <a:rPr sz="2500" b="1">
+                <a:solidFill>
+                  <a:srgbClr val="22303C"/>
+                </a:solidFill>
+                <a:latin typeface="Century Gothic"/>
+              </a:rPr>
+              <a:t>Vetted question content</a:t>
+            </a:r>
+            <a:r>
+              <a:rPr sz="2500" b="0">
+                <a:solidFill>
+                  <a:srgbClr val="22303C"/>
+                </a:solidFill>
+                <a:latin typeface="Century Gothic"/>
+              </a:rPr>
+              <a:t> and </a:t>
+            </a:r>
+            <a:r>
+              <a:rPr sz="2500" b="1">
+                <a:solidFill>
+                  <a:srgbClr val="22303C"/>
+                </a:solidFill>
+                <a:latin typeface="Century Gothic"/>
+              </a:rPr>
+              <a:t>deployed to the cloud</a:t>
+            </a:r>
+            <a:r>
+              <a:rPr sz="2500" b="0">
+                <a:solidFill>
+                  <a:srgbClr val="22303C"/>
+                </a:solidFill>
+                <a:latin typeface="Century Gothic"/>
+              </a:rPr>
+              <a:t>.</a:t>
             </a:r>
           </a:p>
           <a:p>
             <a:pPr algn="l">
               <a:spcBef>
-                <a:spcPts val="1600"/>
+                <a:spcPts val="1400"/>
               </a:spcBef>
               <a:spcAft>
                 <a:spcPts val="500"/>
               </a:spcAft>
             </a:pPr>
             <a:r>
-              <a:rPr sz="4200" b="1">
+              <a:rPr sz="4000" b="1">
                 <a:solidFill>
                   <a:srgbClr val="B23E65"/>
                 </a:solidFill>
                 <a:latin typeface="Century Gothic"/>
               </a:rPr>
-              <a:t>ACHIEVEMENTS:</a:t>
+              <a:t>PROJECT TITLE &amp; SYNOPSIS:</a:t>
+            </a:r>
+          </a:p>
+          <a:p>
+            <a:pPr algn="l">
+              <a:spcAft>
+                <a:spcPts val="800"/>
+              </a:spcAft>
+            </a:pPr>
+            <a:r>
+              <a:rPr sz="2800" b="1">
+                <a:solidFill>
+                  <a:srgbClr val="22303C"/>
+                </a:solidFill>
+                <a:latin typeface="Century Gothic"/>
+              </a:rPr>
+              <a:t>A Gamified Study-Habit App Powered by an Exam-Paper Extraction Pipeline</a:t>
             </a:r>
           </a:p>
           <a:p>
@@ -4871,13 +5070,40 @@
               </a:spcAft>
             </a:pPr>
             <a:r>
-              <a:rPr sz="2700" b="0">
-                <a:solidFill>
-                  <a:srgbClr val="22303C"/>
-                </a:solidFill>
-                <a:latin typeface="Century Gothic"/>
-              </a:rPr>
-              <a:t>•  Processed ~130 exam papers into a structured question bank across 5 levels.</a:t>
+              <a:rPr sz="2500" b="0">
+                <a:solidFill>
+                  <a:srgbClr val="22303C"/>
+                </a:solidFill>
+                <a:latin typeface="Century Gothic"/>
+              </a:rPr>
+              <a:t>•  </a:t>
+            </a:r>
+            <a:r>
+              <a:rPr sz="2500" b="0">
+                <a:solidFill>
+                  <a:srgbClr val="22303C"/>
+                </a:solidFill>
+                <a:latin typeface="Century Gothic"/>
+              </a:rPr>
+              <a:t>Builds a </a:t>
+            </a:r>
+            <a:r>
+              <a:rPr sz="2500" b="1">
+                <a:solidFill>
+                  <a:srgbClr val="22303C"/>
+                </a:solidFill>
+                <a:latin typeface="Century Gothic"/>
+              </a:rPr>
+              <a:t>consistent daily study habit</a:t>
+            </a:r>
+            <a:r>
+              <a:rPr sz="2500" b="0">
+                <a:solidFill>
+                  <a:srgbClr val="22303C"/>
+                </a:solidFill>
+                <a:latin typeface="Century Gothic"/>
+              </a:rPr>
+              <a:t> using real exam questions.</a:t>
             </a:r>
           </a:p>
           <a:p>
@@ -4887,13 +5113,40 @@
               </a:spcAft>
             </a:pPr>
             <a:r>
-              <a:rPr sz="2700" b="0">
-                <a:solidFill>
-                  <a:srgbClr val="22303C"/>
-                </a:solidFill>
-                <a:latin typeface="Century Gothic"/>
-              </a:rPr>
-              <a:t>•  Built and deployed Ooka end-to-end; now testing with ~22 students.</a:t>
+              <a:rPr sz="2500" b="0">
+                <a:solidFill>
+                  <a:srgbClr val="22303C"/>
+                </a:solidFill>
+                <a:latin typeface="Century Gothic"/>
+              </a:rPr>
+              <a:t>•  </a:t>
+            </a:r>
+            <a:r>
+              <a:rPr sz="2500" b="0">
+                <a:solidFill>
+                  <a:srgbClr val="22303C"/>
+                </a:solidFill>
+                <a:latin typeface="Century Gothic"/>
+              </a:rPr>
+              <a:t>An </a:t>
+            </a:r>
+            <a:r>
+              <a:rPr sz="2500" b="1">
+                <a:solidFill>
+                  <a:srgbClr val="22303C"/>
+                </a:solidFill>
+                <a:latin typeface="Century Gothic"/>
+              </a:rPr>
+              <a:t>automated pipeline</a:t>
+            </a:r>
+            <a:r>
+              <a:rPr sz="2500" b="0">
+                <a:solidFill>
+                  <a:srgbClr val="22303C"/>
+                </a:solidFill>
+                <a:latin typeface="Century Gothic"/>
+              </a:rPr>
+              <a:t> turns exam papers into the app's question bank.</a:t>
             </a:r>
           </a:p>
           <a:p>
@@ -4903,32 +5156,59 @@
               </a:spcAft>
             </a:pPr>
             <a:r>
-              <a:rPr sz="2700" b="0">
-                <a:solidFill>
-                  <a:srgbClr val="22303C"/>
-                </a:solidFill>
-                <a:latin typeface="Century Gothic"/>
-              </a:rPr>
-              <a:t>•  Redesigned progression from grade-style ranks to a consistency-based XP system.</a:t>
+              <a:rPr sz="2500" b="0">
+                <a:solidFill>
+                  <a:srgbClr val="22303C"/>
+                </a:solidFill>
+                <a:latin typeface="Century Gothic"/>
+              </a:rPr>
+              <a:t>•  </a:t>
+            </a:r>
+            <a:r>
+              <a:rPr sz="2500" b="0">
+                <a:solidFill>
+                  <a:srgbClr val="22303C"/>
+                </a:solidFill>
+                <a:latin typeface="Century Gothic"/>
+              </a:rPr>
+              <a:t>Students get an </a:t>
+            </a:r>
+            <a:r>
+              <a:rPr sz="2500" b="1">
+                <a:solidFill>
+                  <a:srgbClr val="22303C"/>
+                </a:solidFill>
+                <a:latin typeface="Century Gothic"/>
+              </a:rPr>
+              <a:t>explanation the moment they answer</a:t>
+            </a:r>
+            <a:r>
+              <a:rPr sz="2500" b="0">
+                <a:solidFill>
+                  <a:srgbClr val="22303C"/>
+                </a:solidFill>
+                <a:latin typeface="Century Gothic"/>
+              </a:rPr>
+              <a:t>; streaks and XP keep them practising.</a:t>
             </a:r>
           </a:p>
           <a:p>
             <a:pPr algn="l">
               <a:spcBef>
-                <a:spcPts val="1600"/>
+                <a:spcPts val="1400"/>
               </a:spcBef>
               <a:spcAft>
                 <a:spcPts val="500"/>
               </a:spcAft>
             </a:pPr>
             <a:r>
-              <a:rPr sz="4200" b="1">
+              <a:rPr sz="4000" b="1">
                 <a:solidFill>
                   <a:srgbClr val="B23E65"/>
                 </a:solidFill>
                 <a:latin typeface="Century Gothic"/>
               </a:rPr>
-              <a:t>REFLECTIONS:</a:t>
+              <a:t>IMPACT &amp; OUTCOME:</a:t>
             </a:r>
           </a:p>
           <a:p>
@@ -4938,13 +5218,31 @@
               </a:spcAft>
             </a:pPr>
             <a:r>
-              <a:rPr sz="2700" b="0">
-                <a:solidFill>
-                  <a:srgbClr val="22303C"/>
-                </a:solidFill>
-                <a:latin typeface="Century Gothic"/>
-              </a:rPr>
-              <a:t>•  Applied the CDIO framework across the whole project.</a:t>
+              <a:rPr sz="2500" b="0">
+                <a:solidFill>
+                  <a:srgbClr val="22303C"/>
+                </a:solidFill>
+                <a:latin typeface="Century Gothic"/>
+              </a:rPr>
+              <a:t>•  </a:t>
+            </a:r>
+            <a:r>
+              <a:rPr sz="2500" b="1">
+                <a:solidFill>
+                  <a:srgbClr val="22303C"/>
+                </a:solidFill>
+                <a:latin typeface="Century Gothic"/>
+              </a:rPr>
+              <a:t>~130 exam papers</a:t>
+            </a:r>
+            <a:r>
+              <a:rPr sz="2500" b="0">
+                <a:solidFill>
+                  <a:srgbClr val="22303C"/>
+                </a:solidFill>
+                <a:latin typeface="Century Gothic"/>
+              </a:rPr>
+              <a:t> processed into a reusable question bank.</a:t>
             </a:r>
           </a:p>
           <a:p>
@@ -4954,13 +5252,31 @@
               </a:spcAft>
             </a:pPr>
             <a:r>
-              <a:rPr sz="2700" b="0">
-                <a:solidFill>
-                  <a:srgbClr val="22303C"/>
-                </a:solidFill>
-                <a:latin typeface="Century Gothic"/>
-              </a:rPr>
-              <a:t>•  Strengthened full-stack skills and learned to design for real users.</a:t>
+              <a:rPr sz="2500" b="0">
+                <a:solidFill>
+                  <a:srgbClr val="22303C"/>
+                </a:solidFill>
+                <a:latin typeface="Century Gothic"/>
+              </a:rPr>
+              <a:t>•  </a:t>
+            </a:r>
+            <a:r>
+              <a:rPr sz="2500" b="1">
+                <a:solidFill>
+                  <a:srgbClr val="22303C"/>
+                </a:solidFill>
+                <a:latin typeface="Century Gothic"/>
+              </a:rPr>
+              <a:t>5 subjects / levels</a:t>
+            </a:r>
+            <a:r>
+              <a:rPr sz="2500" b="0">
+                <a:solidFill>
+                  <a:srgbClr val="22303C"/>
+                </a:solidFill>
+                <a:latin typeface="Century Gothic"/>
+              </a:rPr>
+              <a:t> shipped: Pure Physics, Combined G1/G2/G3, P6 Math.</a:t>
             </a:r>
           </a:p>
           <a:p>
@@ -4970,13 +5286,92 @@
               </a:spcAft>
             </a:pPr>
             <a:r>
-              <a:rPr sz="2700" b="0">
-                <a:solidFill>
-                  <a:srgbClr val="22303C"/>
-                </a:solidFill>
-                <a:latin typeface="Century Gothic"/>
-              </a:rPr>
-              <a:t>•  Grew in communication and self-directed learning through supervisor feedback.</a:t>
+              <a:rPr sz="2500" b="0">
+                <a:solidFill>
+                  <a:srgbClr val="22303C"/>
+                </a:solidFill>
+                <a:latin typeface="Century Gothic"/>
+              </a:rPr>
+              <a:t>•  </a:t>
+            </a:r>
+            <a:r>
+              <a:rPr sz="2500" b="1">
+                <a:solidFill>
+                  <a:srgbClr val="22303C"/>
+                </a:solidFill>
+                <a:latin typeface="Century Gothic"/>
+              </a:rPr>
+              <a:t>Deployed to production</a:t>
+            </a:r>
+            <a:r>
+              <a:rPr sz="2500" b="0">
+                <a:solidFill>
+                  <a:srgbClr val="22303C"/>
+                </a:solidFill>
+                <a:latin typeface="Century Gothic"/>
+              </a:rPr>
+              <a:t>, now testing with </a:t>
+            </a:r>
+            <a:r>
+              <a:rPr sz="2500" b="1">
+                <a:solidFill>
+                  <a:srgbClr val="22303C"/>
+                </a:solidFill>
+                <a:latin typeface="Century Gothic"/>
+              </a:rPr>
+              <a:t>~22 students</a:t>
+            </a:r>
+            <a:r>
+              <a:rPr sz="2500" b="0">
+                <a:solidFill>
+                  <a:srgbClr val="22303C"/>
+                </a:solidFill>
+                <a:latin typeface="Century Gothic"/>
+              </a:rPr>
+              <a:t>.</a:t>
+            </a:r>
+          </a:p>
+          <a:p>
+            <a:pPr algn="l" marL="342900" indent="-342900">
+              <a:spcAft>
+                <a:spcPts val="800"/>
+              </a:spcAft>
+            </a:pPr>
+            <a:r>
+              <a:rPr sz="2500" b="0">
+                <a:solidFill>
+                  <a:srgbClr val="22303C"/>
+                </a:solidFill>
+                <a:latin typeface="Century Gothic"/>
+              </a:rPr>
+              <a:t>•  </a:t>
+            </a:r>
+            <a:r>
+              <a:rPr sz="2500" b="0">
+                <a:solidFill>
+                  <a:srgbClr val="22303C"/>
+                </a:solidFill>
+                <a:latin typeface="Century Gothic"/>
+              </a:rPr>
+              <a:t>Cut feedback </a:t>
+            </a:r>
+            <a:r>
+              <a:rPr sz="2500" b="1">
+                <a:solidFill>
+                  <a:srgbClr val="22303C"/>
+                </a:solidFill>
+                <a:latin typeface="Century Gothic"/>
+              </a:rPr>
+              <a:t>from days to instant</a:t>
+            </a:r>
+            <a:r>
+              <a:rPr sz="2500" b="0">
+                <a:solidFill>
+                  <a:srgbClr val="22303C"/>
+                </a:solidFill>
+                <a:latin typeface="Century Gothic"/>
+              </a:rPr>
+              <a:t>.</a:t>
             </a:r>
           </a:p>
         </p:txBody>
@@ -4989,8 +5384,8 @@
         </p:nvSpPr>
         <p:spPr>
           <a:xfrm>
-            <a:off x="11242582" y="16824960"/>
-            <a:ext cx="8635319" cy="10332720"/>
+            <a:off x="11247120" y="14721840"/>
+            <a:ext cx="8869680" cy="12070080"/>
           </a:xfrm>
           <a:prstGeom prst="rect">
             <a:avLst/>
@@ -5003,294 +5398,391 @@
           <a:lstStyle/>
           <a:p>
             <a:pPr algn="l">
-              <a:spcAft>
-                <a:spcPts val="500"/>
-              </a:spcAft>
-            </a:pPr>
-            <a:r>
-              <a:rPr sz="3400" b="1">
-                <a:solidFill>
-                  <a:srgbClr val="B23E65"/>
-                </a:solidFill>
-                <a:latin typeface="Century Gothic"/>
-              </a:rPr>
-              <a:t>PROJECT TITLE &amp; SYNOPSIS:</a:t>
-            </a:r>
-          </a:p>
-          <a:p>
-            <a:pPr algn="l">
-              <a:spcAft>
-                <a:spcPts val="600"/>
-              </a:spcAft>
-            </a:pPr>
-            <a:r>
-              <a:rPr sz="2300" b="1">
-                <a:solidFill>
-                  <a:srgbClr val="22303C"/>
-                </a:solidFill>
-                <a:latin typeface="Century Gothic"/>
-              </a:rPr>
-              <a:t>Ooka — A Gamified Study-Habit App Powered by an Exam-Paper Extraction Pipeline</a:t>
-            </a:r>
-          </a:p>
-          <a:p>
-            <a:pPr algn="l" marL="342900" indent="-342900">
-              <a:spcAft>
-                <a:spcPts val="500"/>
-              </a:spcAft>
-            </a:pPr>
-            <a:r>
-              <a:rPr sz="2200" b="0">
-                <a:solidFill>
-                  <a:srgbClr val="22303C"/>
-                </a:solidFill>
-                <a:latin typeface="Century Gothic"/>
-              </a:rPr>
-              <a:t>•  Helps students build a consistent daily study habit using real exam questions.</a:t>
-            </a:r>
-          </a:p>
-          <a:p>
-            <a:pPr algn="l" marL="342900" indent="-342900">
-              <a:spcAft>
-                <a:spcPts val="500"/>
-              </a:spcAft>
-            </a:pPr>
-            <a:r>
-              <a:rPr sz="2200" b="0">
-                <a:solidFill>
-                  <a:srgbClr val="22303C"/>
-                </a:solidFill>
-                <a:latin typeface="Century Gothic"/>
-              </a:rPr>
-              <a:t>•  An automated pipeline converts exam papers into the app's question bank.</a:t>
-            </a:r>
-          </a:p>
-          <a:p>
-            <a:pPr algn="l" marL="342900" indent="-342900">
-              <a:spcAft>
-                <a:spcPts val="500"/>
-              </a:spcAft>
-            </a:pPr>
-            <a:r>
-              <a:rPr sz="2200" b="0">
-                <a:solidFill>
-                  <a:srgbClr val="22303C"/>
-                </a:solidFill>
-                <a:latin typeface="Century Gothic"/>
-              </a:rPr>
-              <a:t>•  Streaks, XP and rewards keep practice consistent and effective.</a:t>
-            </a:r>
-          </a:p>
-          <a:p>
-            <a:pPr algn="l">
               <a:spcBef>
-                <a:spcPts val="1100"/>
+                <a:spcPts val="0"/>
               </a:spcBef>
               <a:spcAft>
                 <a:spcPts val="500"/>
               </a:spcAft>
             </a:pPr>
             <a:r>
-              <a:rPr sz="3400" b="1">
+              <a:rPr sz="4000" b="1">
                 <a:solidFill>
                   <a:srgbClr val="B23E65"/>
                 </a:solidFill>
                 <a:latin typeface="Century Gothic"/>
               </a:rPr>
-              <a:t>PROBLEM STATEMENT:</a:t>
+              <a:t>INTERNSHIP EXPERIENCE:</a:t>
             </a:r>
           </a:p>
           <a:p>
             <a:pPr algn="l" marL="342900" indent="-342900">
               <a:spcAft>
-                <a:spcPts val="500"/>
+                <a:spcPts val="800"/>
               </a:spcAft>
             </a:pPr>
             <a:r>
-              <a:rPr sz="2200" b="0">
-                <a:solidFill>
-                  <a:srgbClr val="22303C"/>
-                </a:solidFill>
-                <a:latin typeface="Century Gothic"/>
-              </a:rPr>
-              <a:t>•  Digitising exam papers by hand does not scale.</a:t>
+              <a:rPr sz="2500" b="0">
+                <a:solidFill>
+                  <a:srgbClr val="22303C"/>
+                </a:solidFill>
+                <a:latin typeface="Century Gothic"/>
+              </a:rPr>
+              <a:t>•  </a:t>
+            </a:r>
+            <a:r>
+              <a:rPr sz="2500" b="1">
+                <a:solidFill>
+                  <a:srgbClr val="22303C"/>
+                </a:solidFill>
+                <a:latin typeface="Century Gothic"/>
+              </a:rPr>
+              <a:t>Owned the whole product</a:t>
+            </a:r>
+            <a:r>
+              <a:rPr sz="2500" b="0">
+                <a:solidFill>
+                  <a:srgbClr val="22303C"/>
+                </a:solidFill>
+                <a:latin typeface="Century Gothic"/>
+              </a:rPr>
+              <a:t> as the only developer, from problem statement to a deployed app.</a:t>
             </a:r>
           </a:p>
           <a:p>
             <a:pPr algn="l" marL="342900" indent="-342900">
               <a:spcAft>
-                <a:spcPts val="500"/>
+                <a:spcPts val="800"/>
               </a:spcAft>
             </a:pPr>
             <a:r>
-              <a:rPr sz="2200" b="0">
-                <a:solidFill>
-                  <a:srgbClr val="22303C"/>
-                </a:solidFill>
-                <a:latin typeface="Century Gothic"/>
-              </a:rPr>
-              <a:t>•  Students struggle to practise consistently; grade-style apps discourage effort.</a:t>
+              <a:rPr sz="2500" b="0">
+                <a:solidFill>
+                  <a:srgbClr val="22303C"/>
+                </a:solidFill>
+                <a:latin typeface="Century Gothic"/>
+              </a:rPr>
+              <a:t>•  </a:t>
+            </a:r>
+            <a:r>
+              <a:rPr sz="2500" b="0">
+                <a:solidFill>
+                  <a:srgbClr val="22303C"/>
+                </a:solidFill>
+                <a:latin typeface="Century Gothic"/>
+              </a:rPr>
+              <a:t>Worked closely with my </a:t>
+            </a:r>
+            <a:r>
+              <a:rPr sz="2500" b="1">
+                <a:solidFill>
+                  <a:srgbClr val="22303C"/>
+                </a:solidFill>
+                <a:latin typeface="Century Gothic"/>
+              </a:rPr>
+              <a:t>supervisor and the founder</a:t>
+            </a:r>
+            <a:r>
+              <a:rPr sz="2500" b="0">
+                <a:solidFill>
+                  <a:srgbClr val="22303C"/>
+                </a:solidFill>
+                <a:latin typeface="Century Gothic"/>
+              </a:rPr>
+              <a:t> through weekly updates and roadmap meetings.</a:t>
+            </a:r>
+          </a:p>
+          <a:p>
+            <a:pPr algn="l" marL="342900" indent="-342900">
+              <a:spcAft>
+                <a:spcPts val="800"/>
+              </a:spcAft>
+            </a:pPr>
+            <a:r>
+              <a:rPr sz="2500" b="0">
+                <a:solidFill>
+                  <a:srgbClr val="22303C"/>
+                </a:solidFill>
+                <a:latin typeface="Century Gothic"/>
+              </a:rPr>
+              <a:t>•  </a:t>
+            </a:r>
+            <a:r>
+              <a:rPr sz="2500" b="0">
+                <a:solidFill>
+                  <a:srgbClr val="22303C"/>
+                </a:solidFill>
+                <a:latin typeface="Century Gothic"/>
+              </a:rPr>
+              <a:t>Helped shape </a:t>
+            </a:r>
+            <a:r>
+              <a:rPr sz="2500" b="1">
+                <a:solidFill>
+                  <a:srgbClr val="22303C"/>
+                </a:solidFill>
+                <a:latin typeface="Century Gothic"/>
+              </a:rPr>
+              <a:t>major product decisions</a:t>
+            </a:r>
+            <a:r>
+              <a:rPr sz="2500" b="0">
+                <a:solidFill>
+                  <a:srgbClr val="22303C"/>
+                </a:solidFill>
+                <a:latin typeface="Century Gothic"/>
+              </a:rPr>
+              <a:t>, including the rebrand to Ooka and the </a:t>
+            </a:r>
+            <a:r>
+              <a:rPr sz="2500" b="1">
+                <a:solidFill>
+                  <a:srgbClr val="22303C"/>
+                </a:solidFill>
+                <a:latin typeface="Century Gothic"/>
+              </a:rPr>
+              <a:t>ranks-to-XP switch</a:t>
+            </a:r>
+            <a:r>
+              <a:rPr sz="2500" b="0">
+                <a:solidFill>
+                  <a:srgbClr val="22303C"/>
+                </a:solidFill>
+                <a:latin typeface="Century Gothic"/>
+              </a:rPr>
+              <a:t>.</a:t>
+            </a:r>
+          </a:p>
+          <a:p>
+            <a:pPr algn="l" marL="342900" indent="-342900">
+              <a:spcAft>
+                <a:spcPts val="800"/>
+              </a:spcAft>
+            </a:pPr>
+            <a:r>
+              <a:rPr sz="2500" b="0">
+                <a:solidFill>
+                  <a:srgbClr val="22303C"/>
+                </a:solidFill>
+                <a:latin typeface="Century Gothic"/>
+              </a:rPr>
+              <a:t>•  </a:t>
+            </a:r>
+            <a:r>
+              <a:rPr sz="2500" b="1">
+                <a:solidFill>
+                  <a:srgbClr val="22303C"/>
+                </a:solidFill>
+                <a:latin typeface="Century Gothic"/>
+              </a:rPr>
+              <a:t>Learnt new tools on the job</a:t>
+            </a:r>
+            <a:r>
+              <a:rPr sz="2500" b="0">
+                <a:solidFill>
+                  <a:srgbClr val="22303C"/>
+                </a:solidFill>
+                <a:latin typeface="Century Gothic"/>
+              </a:rPr>
+              <a:t>: OCR, FastAPI, Google APIs, cloud hosting.</a:t>
             </a:r>
           </a:p>
           <a:p>
             <a:pPr algn="l">
               <a:spcBef>
-                <a:spcPts val="1100"/>
+                <a:spcPts val="1400"/>
               </a:spcBef>
               <a:spcAft>
                 <a:spcPts val="500"/>
               </a:spcAft>
             </a:pPr>
             <a:r>
-              <a:rPr sz="3400" b="1">
+              <a:rPr sz="4000" b="1">
                 <a:solidFill>
                   <a:srgbClr val="B23E65"/>
                 </a:solidFill>
                 <a:latin typeface="Century Gothic"/>
               </a:rPr>
-              <a:t>INTERNSHIP EXPERIENCE:</a:t>
+              <a:t>REFLECTIONS:</a:t>
             </a:r>
           </a:p>
           <a:p>
             <a:pPr algn="l" marL="342900" indent="-342900">
               <a:spcAft>
-                <a:spcPts val="500"/>
+                <a:spcPts val="800"/>
               </a:spcAft>
             </a:pPr>
             <a:r>
-              <a:rPr sz="2200" b="0">
-                <a:solidFill>
-                  <a:srgbClr val="22303C"/>
-                </a:solidFill>
-                <a:latin typeface="Century Gothic"/>
-              </a:rPr>
-              <a:t>•  Built the extraction pipeline and the full Ooka app end-to-end.</a:t>
+              <a:rPr sz="2500" b="0">
+                <a:solidFill>
+                  <a:srgbClr val="22303C"/>
+                </a:solidFill>
+                <a:latin typeface="Century Gothic"/>
+              </a:rPr>
+              <a:t>•  </a:t>
+            </a:r>
+            <a:r>
+              <a:rPr sz="2500" b="0">
+                <a:solidFill>
+                  <a:srgbClr val="22303C"/>
+                </a:solidFill>
+                <a:latin typeface="Century Gothic"/>
+              </a:rPr>
+              <a:t>I learned to </a:t>
+            </a:r>
+            <a:r>
+              <a:rPr sz="2500" b="1">
+                <a:solidFill>
+                  <a:srgbClr val="22303C"/>
+                </a:solidFill>
+                <a:latin typeface="Century Gothic"/>
+              </a:rPr>
+              <a:t>teach myself new technologies</a:t>
+            </a:r>
+            <a:r>
+              <a:rPr sz="2500" b="0">
+                <a:solidFill>
+                  <a:srgbClr val="22303C"/>
+                </a:solidFill>
+                <a:latin typeface="Century Gothic"/>
+              </a:rPr>
+              <a:t> with no formal training, picking up OCR, FastAPI and cloud deployment as the work needed them.</a:t>
             </a:r>
           </a:p>
           <a:p>
             <a:pPr algn="l" marL="342900" indent="-342900">
               <a:spcAft>
-                <a:spcPts val="500"/>
+                <a:spcPts val="800"/>
               </a:spcAft>
             </a:pPr>
             <a:r>
-              <a:rPr sz="2200" b="0">
-                <a:solidFill>
-                  <a:srgbClr val="22303C"/>
-                </a:solidFill>
-                <a:latin typeface="Century Gothic"/>
-              </a:rPr>
-              <a:t>•  Extended it to the new MOE syllabus (Combined G1/G2/G3, Pure) and P6 Math.</a:t>
+              <a:rPr sz="2500" b="0">
+                <a:solidFill>
+                  <a:srgbClr val="22303C"/>
+                </a:solidFill>
+                <a:latin typeface="Century Gothic"/>
+              </a:rPr>
+              <a:t>•  </a:t>
+            </a:r>
+            <a:r>
+              <a:rPr sz="2500" b="0">
+                <a:solidFill>
+                  <a:srgbClr val="22303C"/>
+                </a:solidFill>
+                <a:latin typeface="Century Gothic"/>
+              </a:rPr>
+              <a:t>I learned to </a:t>
+            </a:r>
+            <a:r>
+              <a:rPr sz="2500" b="1">
+                <a:solidFill>
+                  <a:srgbClr val="22303C"/>
+                </a:solidFill>
+                <a:latin typeface="Century Gothic"/>
+              </a:rPr>
+              <a:t>build and run a whole production system</a:t>
+            </a:r>
+            <a:r>
+              <a:rPr sz="2500" b="0">
+                <a:solidFill>
+                  <a:srgbClr val="22303C"/>
+                </a:solidFill>
+                <a:latin typeface="Century Gothic"/>
+              </a:rPr>
+              <a:t>, not just code that works on my laptop — deploying it, handling real data and keeping it live for students.</a:t>
             </a:r>
           </a:p>
           <a:p>
             <a:pPr algn="l" marL="342900" indent="-342900">
               <a:spcAft>
-                <a:spcPts val="500"/>
+                <a:spcPts val="800"/>
               </a:spcAft>
             </a:pPr>
             <a:r>
-              <a:rPr sz="2200" b="0">
-                <a:solidFill>
-                  <a:srgbClr val="22303C"/>
-                </a:solidFill>
-                <a:latin typeface="Century Gothic"/>
-              </a:rPr>
-              <a:t>•  Solved hard problems in diagram extraction, streak logic and performance.</a:t>
+              <a:rPr sz="2500" b="0">
+                <a:solidFill>
+                  <a:srgbClr val="22303C"/>
+                </a:solidFill>
+                <a:latin typeface="Century Gothic"/>
+              </a:rPr>
+              <a:t>•  </a:t>
+            </a:r>
+            <a:r>
+              <a:rPr sz="2500" b="0">
+                <a:solidFill>
+                  <a:srgbClr val="22303C"/>
+                </a:solidFill>
+                <a:latin typeface="Century Gothic"/>
+              </a:rPr>
+              <a:t>I got much better at </a:t>
+            </a:r>
+            <a:r>
+              <a:rPr sz="2500" b="1">
+                <a:solidFill>
+                  <a:srgbClr val="22303C"/>
+                </a:solidFill>
+                <a:latin typeface="Century Gothic"/>
+              </a:rPr>
+              <a:t>communicating my work</a:t>
+            </a:r>
+            <a:r>
+              <a:rPr sz="2500" b="0">
+                <a:solidFill>
+                  <a:srgbClr val="22303C"/>
+                </a:solidFill>
+                <a:latin typeface="Century Gothic"/>
+              </a:rPr>
+              <a:t>, framing problems and progress clearly for my supervisor and the founder.</a:t>
             </a:r>
           </a:p>
           <a:p>
             <a:pPr algn="l" marL="342900" indent="-342900">
               <a:spcAft>
-                <a:spcPts val="500"/>
+                <a:spcPts val="800"/>
               </a:spcAft>
             </a:pPr>
             <a:r>
-              <a:rPr sz="2200" b="0">
-                <a:solidFill>
-                  <a:srgbClr val="22303C"/>
-                </a:solidFill>
-                <a:latin typeface="Century Gothic"/>
-              </a:rPr>
-              <a:t>•  Worked closely with my supervisor on the app's direction and rebrand.</a:t>
-            </a:r>
-          </a:p>
-        </p:txBody>
-      </p:sp>
-      <p:sp>
-        <p:nvSpPr>
-          <p:cNvPr id="29" name="Rounded Rectangle 28"/>
-          <p:cNvSpPr/>
-          <p:nvPr/>
-        </p:nvSpPr>
-        <p:spPr>
-          <a:xfrm>
-            <a:off x="11486963" y="5643777"/>
-            <a:ext cx="3208060" cy="1672530"/>
-          </a:xfrm>
-          <a:prstGeom prst="roundRect">
-            <a:avLst/>
-          </a:prstGeom>
-          <a:solidFill>
-            <a:schemeClr val="bg1">
-              <a:lumMod val="85000"/>
-            </a:schemeClr>
-          </a:solidFill>
-          <a:ln>
-            <a:noFill/>
-          </a:ln>
-        </p:spPr>
-        <p:style>
-          <a:lnRef idx="2">
-            <a:schemeClr val="accent1">
-              <a:shade val="50000"/>
-            </a:schemeClr>
-          </a:lnRef>
-          <a:fillRef idx="1">
-            <a:schemeClr val="accent1"/>
-          </a:fillRef>
-          <a:effectRef idx="0">
-            <a:schemeClr val="accent1"/>
-          </a:effectRef>
-          <a:fontRef idx="minor">
-            <a:schemeClr val="lt1"/>
-          </a:fontRef>
-        </p:style>
-        <p:txBody>
-          <a:bodyPr rtlCol="0" anchor="ctr"/>
-          <a:lstStyle/>
-          <a:p>
-            <a:pPr algn="ctr"/>
-            <a:r>
-              <a:rPr lang="en-SG" sz="3600" dirty="0" smtClean="0">
-                <a:solidFill>
-                  <a:schemeClr val="tx1"/>
-                </a:solidFill>
-              </a:rPr>
-              <a:t>Curious Lab</a:t>
-            </a:r>
-          </a:p>
-          <a:p>
-            <a:pPr algn="ctr"/>
-            <a:r>
-              <a:rPr lang="en-SG" sz="3600" dirty="0" smtClean="0">
-                <a:solidFill>
-                  <a:schemeClr val="tx1"/>
-                </a:solidFill>
-              </a:rPr>
-              <a:t>logo</a:t>
-            </a:r>
-            <a:endParaRPr lang="en-SG" sz="3600" dirty="0">
-              <a:solidFill>
-                <a:schemeClr val="tx1"/>
-              </a:solidFill>
-            </a:endParaRPr>
+              <a:rPr sz="2500" b="0">
+                <a:solidFill>
+                  <a:srgbClr val="22303C"/>
+                </a:solidFill>
+                <a:latin typeface="Century Gothic"/>
+              </a:rPr>
+              <a:t>•  </a:t>
+            </a:r>
+            <a:r>
+              <a:rPr sz="2500" b="0">
+                <a:solidFill>
+                  <a:srgbClr val="22303C"/>
+                </a:solidFill>
+                <a:latin typeface="Century Gothic"/>
+              </a:rPr>
+              <a:t>Most of all, I want to </a:t>
+            </a:r>
+            <a:r>
+              <a:rPr sz="2500" b="1">
+                <a:solidFill>
+                  <a:srgbClr val="22303C"/>
+                </a:solidFill>
+                <a:latin typeface="Century Gothic"/>
+              </a:rPr>
+              <a:t>build things that real people use</a:t>
+            </a:r>
+            <a:r>
+              <a:rPr sz="2500" b="0">
+                <a:solidFill>
+                  <a:srgbClr val="22303C"/>
+                </a:solidFill>
+                <a:latin typeface="Century Gothic"/>
+              </a:rPr>
+              <a:t>. Seeing students actually learn with Ooka was the most rewarding part.</a:t>
+            </a:r>
           </a:p>
         </p:txBody>
       </p:sp>
       <p:pic>
         <p:nvPicPr>
-          <p:cNvPr id="30" name="Picture 29" descr="ooka_architecture.png"/>
+          <p:cNvPr id="35" name="Picture 34" descr="curious_logo.png"/>
           <p:cNvPicPr>
             <a:picLocks noChangeAspect="1"/>
           </p:cNvPicPr>
@@ -5304,127 +5796,124 @@
         </p:blipFill>
         <p:spPr>
           <a:xfrm>
-            <a:off x="11247120" y="7589520"/>
-            <a:ext cx="9784080" cy="7708669"/>
+            <a:off x="11795760" y="5486400"/>
+            <a:ext cx="1874519" cy="1874519"/>
           </a:xfrm>
           <a:prstGeom prst="rect">
             <a:avLst/>
           </a:prstGeom>
         </p:spPr>
       </p:pic>
-      <p:sp>
-        <p:nvSpPr>
-          <p:cNvPr id="31" name="Rectangle 30"/>
-          <p:cNvSpPr/>
+      <p:pic>
+        <p:nvPicPr>
+          <p:cNvPr id="36" name="Picture 35" descr="ooka_04_question_with_diagram.png"/>
+          <p:cNvPicPr>
+            <a:picLocks noChangeAspect="1"/>
+          </p:cNvPicPr>
           <p:nvPr/>
-        </p:nvSpPr>
+        </p:nvPicPr>
+        <p:blipFill>
+          <a:blip r:embed="rId7"/>
+          <a:stretch>
+            <a:fillRect/>
+          </a:stretch>
+        </p:blipFill>
         <p:spPr>
           <a:xfrm>
-            <a:off x="11247120" y="15316200"/>
-            <a:ext cx="4754880" cy="1325880"/>
+            <a:off x="10881360" y="7680960"/>
+            <a:ext cx="3063240" cy="5857527"/>
           </a:xfrm>
           <a:prstGeom prst="rect">
             <a:avLst/>
           </a:prstGeom>
-          <a:solidFill>
-            <a:srgbClr val="F0EEEA"/>
-          </a:solidFill>
-          <a:ln w="25400">
-            <a:solidFill>
-              <a:srgbClr val="B23E65"/>
-            </a:solidFill>
-            <a:prstDash val="dash"/>
-          </a:ln>
         </p:spPr>
-        <p:style>
-          <a:lnRef idx="1">
-            <a:schemeClr val="accent1"/>
-          </a:lnRef>
-          <a:fillRef idx="3">
-            <a:schemeClr val="accent1"/>
-          </a:fillRef>
-          <a:effectRef idx="2">
-            <a:schemeClr val="accent1"/>
-          </a:effectRef>
-          <a:fontRef idx="minor">
-            <a:schemeClr val="lt1"/>
-          </a:fontRef>
-        </p:style>
-        <p:txBody>
-          <a:bodyPr rtlCol="0" anchor="ctr" wrap="square"/>
-          <a:lstStyle/>
-          <a:p>
-            <a:pPr algn="ctr"/>
-            <a:r>
-              <a:rPr sz="2000" b="1">
-                <a:solidFill>
-                  <a:srgbClr val="888888"/>
-                </a:solidFill>
-                <a:latin typeface="Century Gothic"/>
-              </a:rPr>
-              <a:t>Ooka screenshot  (replace me)</a:t>
-            </a:r>
-          </a:p>
-        </p:txBody>
-      </p:sp>
-      <p:sp>
-        <p:nvSpPr>
-          <p:cNvPr id="32" name="Rectangle 31"/>
-          <p:cNvSpPr/>
+      </p:pic>
+      <p:pic>
+        <p:nvPicPr>
+          <p:cNvPr id="37" name="Picture 36" descr="ooka_01_home.png"/>
+          <p:cNvPicPr>
+            <a:picLocks noChangeAspect="1"/>
+          </p:cNvPicPr>
           <p:nvPr/>
-        </p:nvSpPr>
+        </p:nvPicPr>
+        <p:blipFill>
+          <a:blip r:embed="rId8"/>
+          <a:stretch>
+            <a:fillRect/>
+          </a:stretch>
+        </p:blipFill>
         <p:spPr>
           <a:xfrm>
-            <a:off x="16276320" y="15316200"/>
-            <a:ext cx="4754880" cy="1325880"/>
+            <a:off x="14218920" y="7680960"/>
+            <a:ext cx="3063240" cy="6066746"/>
           </a:xfrm>
           <a:prstGeom prst="rect">
             <a:avLst/>
           </a:prstGeom>
-          <a:solidFill>
-            <a:srgbClr val="F0EEEA"/>
-          </a:solidFill>
-          <a:ln w="25400">
-            <a:solidFill>
-              <a:srgbClr val="B23E65"/>
-            </a:solidFill>
-            <a:prstDash val="dash"/>
-          </a:ln>
         </p:spPr>
-        <p:style>
-          <a:lnRef idx="1">
-            <a:schemeClr val="accent1"/>
-          </a:lnRef>
-          <a:fillRef idx="3">
-            <a:schemeClr val="accent1"/>
-          </a:fillRef>
-          <a:effectRef idx="2">
-            <a:schemeClr val="accent1"/>
-          </a:effectRef>
-          <a:fontRef idx="minor">
-            <a:schemeClr val="lt1"/>
-          </a:fontRef>
-        </p:style>
-        <p:txBody>
-          <a:bodyPr rtlCol="0" anchor="ctr" wrap="square"/>
+      </p:pic>
+      <p:pic>
+        <p:nvPicPr>
+          <p:cNvPr id="38" name="Picture 37" descr="ooka_07_leaderboard.png"/>
+          <p:cNvPicPr>
+            <a:picLocks noChangeAspect="1"/>
+          </p:cNvPicPr>
+          <p:nvPr/>
+        </p:nvPicPr>
+        <p:blipFill>
+          <a:blip r:embed="rId9"/>
+          <a:stretch>
+            <a:fillRect/>
+          </a:stretch>
+        </p:blipFill>
+        <p:spPr>
+          <a:xfrm>
+            <a:off x="17556480" y="7680960"/>
+            <a:ext cx="3063240" cy="5857527"/>
+          </a:xfrm>
+          <a:prstGeom prst="rect">
+            <a:avLst/>
+          </a:prstGeom>
+        </p:spPr>
+      </p:pic>
+      <p:sp>
+        <p:nvSpPr>
+          <p:cNvPr id="39" name="TextBox 38"/>
+          <p:cNvSpPr txBox="1"/>
+          <p:nvPr/>
+        </p:nvSpPr>
+        <p:spPr>
+          <a:xfrm>
+            <a:off x="10881360" y="13944600"/>
+            <a:ext cx="9784080" cy="457200"/>
+          </a:xfrm>
+          <a:prstGeom prst="rect">
+            <a:avLst/>
+          </a:prstGeom>
+          <a:noFill/>
+        </p:spPr>
+        <p:txBody>
+          <a:bodyPr wrap="none">
+            <a:spAutoFit/>
+          </a:bodyPr>
           <a:lstStyle/>
           <a:p>
             <a:pPr algn="ctr"/>
             <a:r>
-              <a:rPr sz="2000" b="1">
-                <a:solidFill>
-                  <a:srgbClr val="888888"/>
-                </a:solidFill>
-                <a:latin typeface="Century Gothic"/>
-              </a:rPr>
-              <a:t>Ooka screenshot  (replace me)</a:t>
-            </a:r>
-          </a:p>
-        </p:txBody>
-      </p:sp>
-      <p:sp>
-        <p:nvSpPr>
-          <p:cNvPr id="33" name="Rectangle 32"/>
+              <a:rPr sz="1500" i="1">
+                <a:solidFill>
+                  <a:srgbClr val="5A6672"/>
+                </a:solidFill>
+                <a:latin typeface="Century Gothic"/>
+              </a:rPr>
+              <a:t>The live Ooka app: a question with its extracted diagram, the daily streak, and the leaderboard.</a:t>
+            </a:r>
+          </a:p>
+        </p:txBody>
+      </p:sp>
+      <p:sp>
+        <p:nvSpPr>
+          <p:cNvPr id="40" name="Rectangle 39"/>
           <p:cNvSpPr/>
           <p:nvPr/>
         </p:nvSpPr>
@@ -5467,7 +5956,7 @@
       </p:sp>
       <p:sp>
         <p:nvSpPr>
-          <p:cNvPr id="34" name="Rectangle 33"/>
+          <p:cNvPr id="41" name="Rectangle 40"/>
           <p:cNvSpPr/>
           <p:nvPr/>
         </p:nvSpPr>
@@ -5510,7 +5999,7 @@
       </p:sp>
       <p:sp>
         <p:nvSpPr>
-          <p:cNvPr id="35" name="Rounded Rectangle 34"/>
+          <p:cNvPr id="42" name="Rounded Rectangle 41"/>
           <p:cNvSpPr/>
           <p:nvPr/>
         </p:nvSpPr>
@@ -5562,7 +6051,7 @@
       </p:sp>
       <p:sp>
         <p:nvSpPr>
-          <p:cNvPr id="36" name="TextBox 35"/>
+          <p:cNvPr id="43" name="TextBox 42"/>
           <p:cNvSpPr txBox="1"/>
           <p:nvPr/>
         </p:nvSpPr>

</xml_diff>